<commit_message>
Updated design and read me
</commit_message>
<xml_diff>
--- a/docs/FitTrackLite-wireframe.pptx
+++ b/docs/FitTrackLite-wireframe.pptx
@@ -4,12 +4,12 @@
   <p:sldMasterIdLst>
     <p:sldMasterId id="2147483648" r:id="rId1"/>
   </p:sldMasterIdLst>
+  <p:sldIdLst>
+    <p:sldId id="256" r:id="rId2"/>
+  </p:sldIdLst>
   <p:notesMasterIdLst>
     <p:notesMasterId r:id="rId3"/>
   </p:notesMasterIdLst>
-  <p:sldIdLst>
-    <p:sldId id="256" r:id="rId2"/>
-  </p:sldIdLst>
   <p:sldSz cx="12192000" cy="6858000"/>
   <p:notesSz cx="6858000" cy="12192000"/>
   <p:defaultTextStyle>
@@ -104,11 +104,6 @@
       </a:defRPr>
     </a:lvl9pPr>
   </p:defaultTextStyle>
-  <p:extLst>
-    <p:ext uri="{EFAFB233-063F-42B5-8137-9DF3F51BA10A}">
-      <p15:sldGuideLst xmlns:p15="http://schemas.microsoft.com/office/powerpoint/2012/main"/>
-    </p:ext>
-  </p:extLst>
 </p:presentation>
 </file>
 
@@ -134,10 +129,234 @@
           <a:chExt cx="0" cy="0"/>
         </a:xfrm>
       </p:grpSpPr>
+      <p:sp>
+        <p:nvSpPr>
+          <p:cNvPr id="2" name="Header Placeholder 1"/>
+          <p:cNvSpPr>
+            <a:spLocks noGrp="1"/>
+          </p:cNvSpPr>
+          <p:nvPr>
+            <p:ph type="hdr" sz="quarter"/>
+          </p:nvPr>
+        </p:nvSpPr>
+        <p:spPr>
+          <a:xfrm>
+            <a:off x="0" y="0"/>
+            <a:ext cx="2971800" cy="458788"/>
+          </a:xfrm>
+          <a:prstGeom prst="rect">
+            <a:avLst/>
+          </a:prstGeom>
+        </p:spPr>
+        <p:txBody>
+          <a:bodyPr vert="horz" lIns="91440" tIns="45720" rIns="91440" bIns="45720" rtlCol="0"/>
+          <a:lstStyle>
+            <a:lvl1pPr algn="l">
+              <a:defRPr sz="1200"/>
+            </a:lvl1pPr>
+          </a:lstStyle>
+          <a:p>
+            <a:endParaRPr lang="en-US"/>
+          </a:p>
+        </p:txBody>
+      </p:sp>
+      <p:sp>
+        <p:nvSpPr>
+          <p:cNvPr id="3" name="Date Placeholder 2"/>
+          <p:cNvSpPr>
+            <a:spLocks noGrp="1"/>
+          </p:cNvSpPr>
+          <p:nvPr>
+            <p:ph type="dt" idx="1"/>
+          </p:nvPr>
+        </p:nvSpPr>
+        <p:spPr>
+          <a:xfrm>
+            <a:off x="3884613" y="0"/>
+            <a:ext cx="2971800" cy="458788"/>
+          </a:xfrm>
+          <a:prstGeom prst="rect">
+            <a:avLst/>
+          </a:prstGeom>
+        </p:spPr>
+        <p:txBody>
+          <a:bodyPr vert="horz" lIns="91440" tIns="45720" rIns="91440" bIns="45720" rtlCol="0"/>
+          <a:lstStyle>
+            <a:lvl1pPr algn="r">
+              <a:defRPr sz="1200"/>
+            </a:lvl1pPr>
+          </a:lstStyle>
+          <a:p>
+            <a:fld id="{5282F153-3F37-0F45-9E97-73ACFA13230C}" type="datetimeFigureOut">
+              <a:rPr lang="en-US"/>
+              <a:t>7/23/19</a:t>
+            </a:fld>
+            <a:endParaRPr lang="en-US"/>
+          </a:p>
+        </p:txBody>
+      </p:sp>
+      <p:sp>
+        <p:nvSpPr>
+          <p:cNvPr id="4" name="Slide Image Placeholder 3"/>
+          <p:cNvSpPr>
+            <a:spLocks noGrp="1" noRot="1" noChangeAspect="1"/>
+          </p:cNvSpPr>
+          <p:nvPr>
+            <p:ph type="sldImg" idx="2"/>
+          </p:nvPr>
+        </p:nvSpPr>
+        <p:spPr>
+          <a:xfrm>
+            <a:off x="685800" y="1143000"/>
+            <a:ext cx="5486400" cy="3086100"/>
+          </a:xfrm>
+          <a:prstGeom prst="rect">
+            <a:avLst/>
+          </a:prstGeom>
+          <a:noFill/>
+          <a:ln w="12700">
+            <a:solidFill>
+              <a:prstClr val="black"/>
+            </a:solidFill>
+          </a:ln>
+        </p:spPr>
+        <p:txBody>
+          <a:bodyPr vert="horz" lIns="91440" tIns="45720" rIns="91440" bIns="45720" rtlCol="0" anchor="ctr"/>
+          <a:lstStyle/>
+          <a:p>
+            <a:endParaRPr lang="en-US"/>
+          </a:p>
+        </p:txBody>
+      </p:sp>
+      <p:sp>
+        <p:nvSpPr>
+          <p:cNvPr id="5" name="Notes Placeholder 4"/>
+          <p:cNvSpPr>
+            <a:spLocks noGrp="1"/>
+          </p:cNvSpPr>
+          <p:nvPr>
+            <p:ph type="body" sz="quarter" idx="3"/>
+          </p:nvPr>
+        </p:nvSpPr>
+        <p:spPr>
+          <a:xfrm>
+            <a:off x="685800" y="4400550"/>
+            <a:ext cx="5486400" cy="3600450"/>
+          </a:xfrm>
+          <a:prstGeom prst="rect">
+            <a:avLst/>
+          </a:prstGeom>
+        </p:spPr>
+        <p:txBody>
+          <a:bodyPr vert="horz" lIns="91440" tIns="45720" rIns="91440" bIns="45720" rtlCol="0"/>
+          <a:lstStyle/>
+          <a:p>
+            <a:pPr lvl="0"/>
+            <a:r>
+              <a:rPr lang="en-US"/>
+              <a:t>Click to edit Master text styles</a:t>
+            </a:r>
+          </a:p>
+          <a:p>
+            <a:pPr lvl="1"/>
+            <a:r>
+              <a:rPr lang="en-US"/>
+              <a:t>Second level</a:t>
+            </a:r>
+          </a:p>
+          <a:p>
+            <a:pPr lvl="2"/>
+            <a:r>
+              <a:rPr lang="en-US"/>
+              <a:t>Third level</a:t>
+            </a:r>
+          </a:p>
+          <a:p>
+            <a:pPr lvl="3"/>
+            <a:r>
+              <a:rPr lang="en-US"/>
+              <a:t>Fourth level</a:t>
+            </a:r>
+          </a:p>
+          <a:p>
+            <a:pPr lvl="4"/>
+            <a:r>
+              <a:rPr lang="en-US"/>
+              <a:t>Fifth level</a:t>
+            </a:r>
+          </a:p>
+        </p:txBody>
+      </p:sp>
+      <p:sp>
+        <p:nvSpPr>
+          <p:cNvPr id="6" name="Footer Placeholder 5"/>
+          <p:cNvSpPr>
+            <a:spLocks noGrp="1"/>
+          </p:cNvSpPr>
+          <p:nvPr>
+            <p:ph type="ftr" sz="quarter" idx="4"/>
+          </p:nvPr>
+        </p:nvSpPr>
+        <p:spPr>
+          <a:xfrm>
+            <a:off x="0" y="8685213"/>
+            <a:ext cx="2971800" cy="458787"/>
+          </a:xfrm>
+          <a:prstGeom prst="rect">
+            <a:avLst/>
+          </a:prstGeom>
+        </p:spPr>
+        <p:txBody>
+          <a:bodyPr vert="horz" lIns="91440" tIns="45720" rIns="91440" bIns="45720" rtlCol="0" anchor="b"/>
+          <a:lstStyle>
+            <a:lvl1pPr algn="l">
+              <a:defRPr sz="1200"/>
+            </a:lvl1pPr>
+          </a:lstStyle>
+          <a:p>
+            <a:endParaRPr lang="en-US"/>
+          </a:p>
+        </p:txBody>
+      </p:sp>
+      <p:sp>
+        <p:nvSpPr>
+          <p:cNvPr id="7" name="Slide Number Placeholder 6"/>
+          <p:cNvSpPr>
+            <a:spLocks noGrp="1"/>
+          </p:cNvSpPr>
+          <p:nvPr>
+            <p:ph type="sldNum" sz="quarter" idx="5"/>
+          </p:nvPr>
+        </p:nvSpPr>
+        <p:spPr>
+          <a:xfrm>
+            <a:off x="3884613" y="8685213"/>
+            <a:ext cx="2971800" cy="458787"/>
+          </a:xfrm>
+          <a:prstGeom prst="rect">
+            <a:avLst/>
+          </a:prstGeom>
+        </p:spPr>
+        <p:txBody>
+          <a:bodyPr vert="horz" lIns="91440" tIns="45720" rIns="91440" bIns="45720" rtlCol="0" anchor="b"/>
+          <a:lstStyle>
+            <a:lvl1pPr algn="r">
+              <a:defRPr sz="1200"/>
+            </a:lvl1pPr>
+          </a:lstStyle>
+          <a:p>
+            <a:fld id="{CE5E9CC1-C706-0F49-92D6-E571CC5EEA8F}" type="slidenum">
+              <a:rPr lang="en-US"/>
+              <a:t>‹#›</a:t>
+            </a:fld>
+            <a:endParaRPr lang="en-US"/>
+          </a:p>
+        </p:txBody>
+      </p:sp>
     </p:spTree>
     <p:extLst>
       <p:ext uri="{BB962C8B-B14F-4D97-AF65-F5344CB8AC3E}">
-        <p14:creationId xmlns:p14="http://schemas.microsoft.com/office/powerpoint/2010/main" val="3177153253"/>
+        <p14:creationId xmlns:p14="http://schemas.microsoft.com/office/powerpoint/2010/main" val="1024086991"/>
       </p:ext>
     </p:extLst>
   </p:cSld>
@@ -281,6 +500,10 @@
           <a:bodyPr/>
           <a:lstStyle/>
           <a:p>
+            <a:r>
+              <a:rPr lang="en-US" dirty="0"/>
+              <a:t/>
+            </a:r>
             <a:endParaRPr lang="en-US" dirty="0"/>
           </a:p>
         </p:txBody>
@@ -354,11 +577,6 @@
 <file path=ppt/slideMasters/slideMaster1.xml><?xml version="1.0" encoding="utf-8"?>
 <p:sldMaster xmlns:a="http://schemas.openxmlformats.org/drawingml/2006/main" xmlns:r="http://schemas.openxmlformats.org/officeDocument/2006/relationships" xmlns:p="http://schemas.openxmlformats.org/presentationml/2006/main">
   <p:cSld>
-    <p:bg>
-      <p:bgRef idx="1001">
-        <a:schemeClr val="bg1"/>
-      </p:bgRef>
-    </p:bg>
     <p:spTree>
       <p:nvGrpSpPr>
         <p:cNvPr id="1" name=""/>
@@ -671,7 +889,7 @@
           <a:bodyPr wrap="square" rtlCol="0" anchor="ctr"/>
           <a:lstStyle/>
           <a:p>
-            <a:pPr marL="0" indent="0">
+            <a:pPr indent="0" marL="0">
               <a:buNone/>
             </a:pPr>
             <a:r>
@@ -688,6 +906,42 @@
       </p:sp>
       <p:sp>
         <p:nvSpPr>
+          <p:cNvPr id="3" name="Text 1"/>
+          <p:cNvSpPr/>
+          <p:nvPr/>
+        </p:nvSpPr>
+        <p:spPr>
+          <a:xfrm>
+            <a:off x="365760" y="594360"/>
+            <a:ext cx="11460175" cy="274320"/>
+          </a:xfrm>
+          <a:prstGeom prst="rect">
+            <a:avLst/>
+          </a:prstGeom>
+          <a:noFill/>
+          <a:ln/>
+        </p:spPr>
+        <p:txBody>
+          <a:bodyPr wrap="square" rtlCol="0" anchor="ctr"/>
+          <a:lstStyle/>
+          <a:p>
+            <a:pPr indent="0" marL="0">
+              <a:buNone/>
+            </a:pPr>
+            <a:r>
+              <a:rPr lang="en-US" sz="1200" dirty="0">
+                <a:solidFill>
+                  <a:srgbClr val="555555"/>
+                </a:solidFill>
+              </a:rPr>
+              <a:t>Boxes and labels only (course wireframe). Edit freely in PowerPoint.</a:t>
+            </a:r>
+            <a:endParaRPr lang="en-US" sz="1200" dirty="0"/>
+          </a:p>
+        </p:txBody>
+      </p:sp>
+      <p:sp>
+        <p:nvSpPr>
           <p:cNvPr id="4" name="Shape 2"/>
           <p:cNvSpPr/>
           <p:nvPr/>
@@ -712,13 +966,6 @@
             <a:prstDash val="solid"/>
           </a:ln>
         </p:spPr>
-        <p:txBody>
-          <a:bodyPr/>
-          <a:lstStyle/>
-          <a:p>
-            <a:endParaRPr lang="en-CA"/>
-          </a:p>
-        </p:txBody>
       </p:sp>
       <p:sp>
         <p:nvSpPr>
@@ -741,7 +988,7 @@
           <a:bodyPr wrap="square" rtlCol="0" anchor="ctr"/>
           <a:lstStyle/>
           <a:p>
-            <a:pPr marL="0" indent="0">
+            <a:pPr indent="0" marL="0">
               <a:buNone/>
             </a:pPr>
             <a:r>
@@ -750,7 +997,7 @@
                   <a:srgbClr val="111111"/>
                 </a:solidFill>
               </a:rPr>
-              <a:t>1. Home</a:t>
+              <a:t>1. Dashboard</a:t>
             </a:r>
             <a:endParaRPr lang="en-US" sz="1400" dirty="0"/>
           </a:p>
@@ -765,13 +1012,13 @@
         <p:spPr>
           <a:xfrm>
             <a:off x="548640" y="1463040"/>
-            <a:ext cx="3240938" cy="384048"/>
-          </a:xfrm>
-          <a:prstGeom prst="rect">
-            <a:avLst/>
-          </a:prstGeom>
-          <a:solidFill>
-            <a:srgbClr val="ECECEC"/>
+            <a:ext cx="3240938" cy="347472"/>
+          </a:xfrm>
+          <a:prstGeom prst="rect">
+            <a:avLst/>
+          </a:prstGeom>
+          <a:solidFill>
+            <a:srgbClr val="C8E6C9"/>
           </a:solidFill>
           <a:ln w="12700">
             <a:solidFill>
@@ -780,13 +1027,6 @@
             <a:prstDash val="solid"/>
           </a:ln>
         </p:spPr>
-        <p:txBody>
-          <a:bodyPr/>
-          <a:lstStyle/>
-          <a:p>
-            <a:endParaRPr lang="en-CA"/>
-          </a:p>
-        </p:txBody>
       </p:sp>
       <p:sp>
         <p:nvSpPr>
@@ -797,7 +1037,7 @@
         <p:spPr>
           <a:xfrm>
             <a:off x="621792" y="1517904"/>
-            <a:ext cx="3094634" cy="274320"/>
+            <a:ext cx="3094634" cy="237744"/>
           </a:xfrm>
           <a:prstGeom prst="rect">
             <a:avLst/>
@@ -809,7 +1049,7 @@
           <a:bodyPr wrap="square" rtlCol="0" anchor="t"/>
           <a:lstStyle/>
           <a:p>
-            <a:pPr marL="0" indent="0">
+            <a:pPr indent="0" marL="0">
               <a:buNone/>
             </a:pPr>
             <a:r>
@@ -818,7 +1058,7 @@
                   <a:srgbClr val="333333"/>
                 </a:solidFill>
               </a:rPr>
-              <a:t>Header: FitTrack Lite Nav: Home | Workouts | Log</a:t>
+              <a:t>Header: logo + Dashboard | Workouts | Add Workout</a:t>
             </a:r>
             <a:endParaRPr lang="en-US" sz="900" dirty="0"/>
           </a:p>
@@ -832,14 +1072,14 @@
         </p:nvSpPr>
         <p:spPr>
           <a:xfrm>
-            <a:off x="548640" y="1920240"/>
-            <a:ext cx="3240938" cy="777240"/>
-          </a:xfrm>
-          <a:prstGeom prst="rect">
-            <a:avLst/>
-          </a:prstGeom>
-          <a:solidFill>
-            <a:srgbClr val="FFFFFF"/>
+            <a:off x="548640" y="1865376"/>
+            <a:ext cx="3240938" cy="502920"/>
+          </a:xfrm>
+          <a:prstGeom prst="rect">
+            <a:avLst/>
+          </a:prstGeom>
+          <a:solidFill>
+            <a:srgbClr val="ECECEC"/>
           </a:solidFill>
           <a:ln w="12700">
             <a:solidFill>
@@ -848,13 +1088,6 @@
             <a:prstDash val="solid"/>
           </a:ln>
         </p:spPr>
-        <p:txBody>
-          <a:bodyPr/>
-          <a:lstStyle/>
-          <a:p>
-            <a:endParaRPr lang="en-CA"/>
-          </a:p>
-        </p:txBody>
       </p:sp>
       <p:sp>
         <p:nvSpPr>
@@ -864,8 +1097,8 @@
         </p:nvSpPr>
         <p:spPr>
           <a:xfrm>
-            <a:off x="621792" y="1975104"/>
-            <a:ext cx="3094634" cy="667512"/>
+            <a:off x="621792" y="1920240"/>
+            <a:ext cx="3094634" cy="393192"/>
           </a:xfrm>
           <a:prstGeom prst="rect">
             <a:avLst/>
@@ -877,18 +1110,18 @@
           <a:bodyPr wrap="square" rtlCol="0" anchor="t"/>
           <a:lstStyle/>
           <a:p>
-            <a:pPr marL="0" indent="0">
+            <a:pPr indent="0" marL="0">
               <a:buNone/>
             </a:pPr>
             <a:r>
-              <a:rPr lang="en-US" sz="1000" dirty="0">
+              <a:rPr lang="en-US" sz="900" dirty="0">
                 <a:solidFill>
                   <a:srgbClr val="333333"/>
                 </a:solidFill>
               </a:rPr>
-              <a:t>Intro / hero copy area</a:t>
-            </a:r>
-            <a:endParaRPr lang="en-US" sz="1000" dirty="0"/>
+              <a:t>3 stat cards: totals, kcal, weekly progress bar</a:t>
+            </a:r>
+            <a:endParaRPr lang="en-US" sz="900" dirty="0"/>
           </a:p>
         </p:txBody>
       </p:sp>
@@ -900,14 +1133,14 @@
         </p:nvSpPr>
         <p:spPr>
           <a:xfrm>
-            <a:off x="548640" y="2788920"/>
-            <a:ext cx="3240938" cy="1005840"/>
-          </a:xfrm>
-          <a:prstGeom prst="rect">
-            <a:avLst/>
-          </a:prstGeom>
-          <a:solidFill>
-            <a:srgbClr val="EEF6FF"/>
+            <a:off x="548640" y="2423160"/>
+            <a:ext cx="3240938" cy="868680"/>
+          </a:xfrm>
+          <a:prstGeom prst="rect">
+            <a:avLst/>
+          </a:prstGeom>
+          <a:solidFill>
+            <a:srgbClr val="E3F2FD"/>
           </a:solidFill>
           <a:ln w="12700">
             <a:solidFill>
@@ -916,13 +1149,6 @@
             <a:prstDash val="solid"/>
           </a:ln>
         </p:spPr>
-        <p:txBody>
-          <a:bodyPr/>
-          <a:lstStyle/>
-          <a:p>
-            <a:endParaRPr lang="en-CA"/>
-          </a:p>
-        </p:txBody>
       </p:sp>
       <p:sp>
         <p:nvSpPr>
@@ -932,8 +1158,8 @@
         </p:nvSpPr>
         <p:spPr>
           <a:xfrm>
-            <a:off x="621792" y="2843784"/>
-            <a:ext cx="3094634" cy="896112"/>
+            <a:off x="621792" y="2478024"/>
+            <a:ext cx="3094634" cy="758952"/>
           </a:xfrm>
           <a:prstGeom prst="rect">
             <a:avLst/>
@@ -945,7 +1171,7 @@
           <a:bodyPr wrap="square" rtlCol="0" anchor="t"/>
           <a:lstStyle/>
           <a:p>
-            <a:pPr marL="0" indent="0">
+            <a:pPr indent="0" marL="0">
               <a:buNone/>
             </a:pPr>
             <a:r>
@@ -954,24 +1180,10 @@
                   <a:srgbClr val="333333"/>
                 </a:solidFill>
               </a:rPr>
-              <a:t>Live widget (fetch)</a:t>
+              <a:t>Daily Motivation (fetch / API Ninjas quote)</a:t>
             </a:r>
             <a:endParaRPr lang="en-US" sz="1000" dirty="0"/>
           </a:p>
-          <a:p>
-            <a:pPr marL="0" indent="0">
-              <a:buNone/>
-            </a:pPr>
-            <a:r>
-              <a:rPr lang="en-US" sz="1000" dirty="0">
-                <a:solidFill>
-                  <a:srgbClr val="333333"/>
-                </a:solidFill>
-              </a:rPr>
-              <a:t>API Ninjas: quote or weather</a:t>
-            </a:r>
-            <a:endParaRPr lang="en-US" sz="1000" dirty="0"/>
-          </a:p>
         </p:txBody>
       </p:sp>
       <p:sp>
@@ -982,14 +1194,14 @@
         </p:nvSpPr>
         <p:spPr>
           <a:xfrm>
-            <a:off x="548640" y="3886200"/>
-            <a:ext cx="3240938" cy="502920"/>
-          </a:xfrm>
-          <a:prstGeom prst="rect">
-            <a:avLst/>
-          </a:prstGeom>
-          <a:solidFill>
-            <a:srgbClr val="F0F0F0"/>
+            <a:off x="548640" y="3364992"/>
+            <a:ext cx="3240938" cy="347472"/>
+          </a:xfrm>
+          <a:prstGeom prst="rect">
+            <a:avLst/>
+          </a:prstGeom>
+          <a:solidFill>
+            <a:srgbClr val="FFF9C4"/>
           </a:solidFill>
           <a:ln w="12700">
             <a:solidFill>
@@ -998,13 +1210,6 @@
             <a:prstDash val="solid"/>
           </a:ln>
         </p:spPr>
-        <p:txBody>
-          <a:bodyPr/>
-          <a:lstStyle/>
-          <a:p>
-            <a:endParaRPr lang="en-CA"/>
-          </a:p>
-        </p:txBody>
       </p:sp>
       <p:sp>
         <p:nvSpPr>
@@ -1014,8 +1219,8 @@
         </p:nvSpPr>
         <p:spPr>
           <a:xfrm>
-            <a:off x="621792" y="3941064"/>
-            <a:ext cx="3094634" cy="393192"/>
+            <a:off x="621792" y="3419856"/>
+            <a:ext cx="3094634" cy="237744"/>
           </a:xfrm>
           <a:prstGeom prst="rect">
             <a:avLst/>
@@ -1027,7 +1232,7 @@
           <a:bodyPr wrap="square" rtlCol="0" anchor="t"/>
           <a:lstStyle/>
           <a:p>
-            <a:pPr marL="0" indent="0">
+            <a:pPr indent="0" marL="0">
               <a:buNone/>
             </a:pPr>
             <a:r>
@@ -1036,7 +1241,7 @@
                   <a:srgbClr val="333333"/>
                 </a:solidFill>
               </a:rPr>
-              <a:t>Footer</a:t>
+              <a:t>Suggested focus (e.g. Try Cardio today)</a:t>
             </a:r>
             <a:endParaRPr lang="en-US" sz="900" dirty="0"/>
           </a:p>
@@ -1045,6 +1250,67 @@
       <p:sp>
         <p:nvSpPr>
           <p:cNvPr id="14" name="Shape 12"/>
+          <p:cNvSpPr/>
+          <p:nvPr/>
+        </p:nvSpPr>
+        <p:spPr>
+          <a:xfrm>
+            <a:off x="548640" y="3767328"/>
+            <a:ext cx="3240938" cy="566928"/>
+          </a:xfrm>
+          <a:prstGeom prst="rect">
+            <a:avLst/>
+          </a:prstGeom>
+          <a:solidFill>
+            <a:srgbClr val="F5F5F5"/>
+          </a:solidFill>
+          <a:ln w="12700">
+            <a:solidFill>
+              <a:srgbClr val="888888"/>
+            </a:solidFill>
+            <a:prstDash val="solid"/>
+          </a:ln>
+        </p:spPr>
+      </p:sp>
+      <p:sp>
+        <p:nvSpPr>
+          <p:cNvPr id="15" name="Text 13"/>
+          <p:cNvSpPr/>
+          <p:nvPr/>
+        </p:nvSpPr>
+        <p:spPr>
+          <a:xfrm>
+            <a:off x="621792" y="3822192"/>
+            <a:ext cx="3094634" cy="457200"/>
+          </a:xfrm>
+          <a:prstGeom prst="rect">
+            <a:avLst/>
+          </a:prstGeom>
+          <a:noFill/>
+          <a:ln/>
+        </p:spPr>
+        <p:txBody>
+          <a:bodyPr wrap="square" rtlCol="0" anchor="t"/>
+          <a:lstStyle/>
+          <a:p>
+            <a:pPr indent="0" marL="0">
+              <a:buNone/>
+            </a:pPr>
+            <a:r>
+              <a:rPr lang="en-US" sz="900" dirty="0">
+                <a:solidFill>
+                  <a:srgbClr val="333333"/>
+                </a:solidFill>
+              </a:rPr>
+              <a:t>Recent workouts — horizontal cards</a:t>
+            </a:r>
+            <a:endParaRPr lang="en-US" sz="900" dirty="0"/>
+          </a:p>
+        </p:txBody>
+      </p:sp>
+      <p:sp>
+        <p:nvSpPr>
+          <p:cNvPr id="16" name="Shape 14"/>
           <p:cNvSpPr/>
           <p:nvPr/>
         </p:nvSpPr>
@@ -1068,17 +1334,10 @@
             <a:prstDash val="solid"/>
           </a:ln>
         </p:spPr>
-        <p:txBody>
-          <a:bodyPr/>
-          <a:lstStyle/>
-          <a:p>
-            <a:endParaRPr lang="en-CA"/>
-          </a:p>
-        </p:txBody>
-      </p:sp>
-      <p:sp>
-        <p:nvSpPr>
-          <p:cNvPr id="15" name="Text 13"/>
+      </p:sp>
+      <p:sp>
+        <p:nvSpPr>
+          <p:cNvPr id="17" name="Text 15"/>
           <p:cNvSpPr/>
           <p:nvPr/>
         </p:nvSpPr>
@@ -1097,7 +1356,7 @@
           <a:bodyPr wrap="square" rtlCol="0" anchor="ctr"/>
           <a:lstStyle/>
           <a:p>
-            <a:pPr marL="0" indent="0">
+            <a:pPr indent="0" marL="0">
               <a:buNone/>
             </a:pPr>
             <a:r>
@@ -1106,7 +1365,7 @@
                   <a:srgbClr val="111111"/>
                 </a:solidFill>
               </a:rPr>
-              <a:t>2. Workouts (gallery)</a:t>
+              <a:t>2. Workouts</a:t>
             </a:r>
             <a:endParaRPr lang="en-US" sz="1400" dirty="0"/>
           </a:p>
@@ -1114,20 +1373,20 @@
       </p:sp>
       <p:sp>
         <p:nvSpPr>
-          <p:cNvPr id="16" name="Shape 14"/>
+          <p:cNvPr id="18" name="Shape 16"/>
           <p:cNvSpPr/>
           <p:nvPr/>
         </p:nvSpPr>
         <p:spPr>
           <a:xfrm>
             <a:off x="4475378" y="1463040"/>
-            <a:ext cx="3240938" cy="384048"/>
-          </a:xfrm>
-          <a:prstGeom prst="rect">
-            <a:avLst/>
-          </a:prstGeom>
-          <a:solidFill>
-            <a:srgbClr val="ECECEC"/>
+            <a:ext cx="3240938" cy="347472"/>
+          </a:xfrm>
+          <a:prstGeom prst="rect">
+            <a:avLst/>
+          </a:prstGeom>
+          <a:solidFill>
+            <a:srgbClr val="C8E6C9"/>
           </a:solidFill>
           <a:ln w="12700">
             <a:solidFill>
@@ -1136,24 +1395,17 @@
             <a:prstDash val="solid"/>
           </a:ln>
         </p:spPr>
-        <p:txBody>
-          <a:bodyPr/>
-          <a:lstStyle/>
-          <a:p>
-            <a:endParaRPr lang="en-CA"/>
-          </a:p>
-        </p:txBody>
-      </p:sp>
-      <p:sp>
-        <p:nvSpPr>
-          <p:cNvPr id="17" name="Text 15"/>
+      </p:sp>
+      <p:sp>
+        <p:nvSpPr>
+          <p:cNvPr id="19" name="Text 17"/>
           <p:cNvSpPr/>
           <p:nvPr/>
         </p:nvSpPr>
         <p:spPr>
           <a:xfrm>
             <a:off x="4548530" y="1517904"/>
-            <a:ext cx="3094634" cy="274320"/>
+            <a:ext cx="3094634" cy="237744"/>
           </a:xfrm>
           <a:prstGeom prst="rect">
             <a:avLst/>
@@ -1165,7 +1417,7 @@
           <a:bodyPr wrap="square" rtlCol="0" anchor="t"/>
           <a:lstStyle/>
           <a:p>
-            <a:pPr marL="0" indent="0">
+            <a:pPr indent="0" marL="0">
               <a:buNone/>
             </a:pPr>
             <a:r>
@@ -1174,7 +1426,7 @@
                   <a:srgbClr val="333333"/>
                 </a:solidFill>
               </a:rPr>
-              <a:t>Same header + nav</a:t>
+              <a:t>Header: Add Workout + menu (mobile)</a:t>
             </a:r>
             <a:endParaRPr lang="en-US" sz="900" dirty="0"/>
           </a:p>
@@ -1182,14 +1434,14 @@
       </p:sp>
       <p:sp>
         <p:nvSpPr>
-          <p:cNvPr id="18" name="Shape 16"/>
-          <p:cNvSpPr/>
-          <p:nvPr/>
-        </p:nvSpPr>
-        <p:spPr>
-          <a:xfrm>
-            <a:off x="4475378" y="1920240"/>
-            <a:ext cx="3240938" cy="347472"/>
+          <p:cNvPr id="20" name="Shape 18"/>
+          <p:cNvSpPr/>
+          <p:nvPr/>
+        </p:nvSpPr>
+        <p:spPr>
+          <a:xfrm>
+            <a:off x="4475378" y="1865376"/>
+            <a:ext cx="1555650" cy="329184"/>
           </a:xfrm>
           <a:prstGeom prst="rect">
             <a:avLst/>
@@ -1204,24 +1456,17 @@
             <a:prstDash val="solid"/>
           </a:ln>
         </p:spPr>
-        <p:txBody>
-          <a:bodyPr/>
-          <a:lstStyle/>
-          <a:p>
-            <a:endParaRPr lang="en-CA"/>
-          </a:p>
-        </p:txBody>
-      </p:sp>
-      <p:sp>
-        <p:nvSpPr>
-          <p:cNvPr id="19" name="Text 17"/>
-          <p:cNvSpPr/>
-          <p:nvPr/>
-        </p:nvSpPr>
-        <p:spPr>
-          <a:xfrm>
-            <a:off x="4548530" y="1975104"/>
-            <a:ext cx="3094634" cy="237744"/>
+      </p:sp>
+      <p:sp>
+        <p:nvSpPr>
+          <p:cNvPr id="21" name="Text 19"/>
+          <p:cNvSpPr/>
+          <p:nvPr/>
+        </p:nvSpPr>
+        <p:spPr>
+          <a:xfrm>
+            <a:off x="4548530" y="1920240"/>
+            <a:ext cx="1409346" cy="219456"/>
           </a:xfrm>
           <a:prstGeom prst="rect">
             <a:avLst/>
@@ -1233,31 +1478,31 @@
           <a:bodyPr wrap="square" rtlCol="0" anchor="t"/>
           <a:lstStyle/>
           <a:p>
-            <a:pPr marL="0" indent="0">
+            <a:pPr indent="0" marL="0">
               <a:buNone/>
             </a:pPr>
             <a:r>
-              <a:rPr lang="en-US" sz="1000" dirty="0">
+              <a:rPr lang="en-US" sz="900" dirty="0">
                 <a:solidFill>
                   <a:srgbClr val="333333"/>
                 </a:solidFill>
               </a:rPr>
-              <a:t>Search / filter (live input)</a:t>
-            </a:r>
-            <a:endParaRPr lang="en-US" sz="1000" dirty="0"/>
-          </a:p>
-        </p:txBody>
-      </p:sp>
-      <p:sp>
-        <p:nvSpPr>
-          <p:cNvPr id="20" name="Shape 18"/>
-          <p:cNvSpPr/>
-          <p:nvPr/>
-        </p:nvSpPr>
-        <p:spPr>
-          <a:xfrm>
-            <a:off x="4475378" y="2359152"/>
-            <a:ext cx="1433017" cy="566928"/>
+              <a:t>Filter dropdown</a:t>
+            </a:r>
+            <a:endParaRPr lang="en-US" sz="900" dirty="0"/>
+          </a:p>
+        </p:txBody>
+      </p:sp>
+      <p:sp>
+        <p:nvSpPr>
+          <p:cNvPr id="22" name="Shape 20"/>
+          <p:cNvSpPr/>
+          <p:nvPr/>
+        </p:nvSpPr>
+        <p:spPr>
+          <a:xfrm>
+            <a:off x="6160666" y="1865376"/>
+            <a:ext cx="1555650" cy="329184"/>
           </a:xfrm>
           <a:prstGeom prst="rect">
             <a:avLst/>
@@ -1272,24 +1517,17 @@
             <a:prstDash val="solid"/>
           </a:ln>
         </p:spPr>
-        <p:txBody>
-          <a:bodyPr/>
-          <a:lstStyle/>
-          <a:p>
-            <a:endParaRPr lang="en-CA"/>
-          </a:p>
-        </p:txBody>
-      </p:sp>
-      <p:sp>
-        <p:nvSpPr>
-          <p:cNvPr id="21" name="Text 19"/>
-          <p:cNvSpPr/>
-          <p:nvPr/>
-        </p:nvSpPr>
-        <p:spPr>
-          <a:xfrm>
-            <a:off x="4548530" y="2414016"/>
-            <a:ext cx="1286713" cy="457200"/>
+      </p:sp>
+      <p:sp>
+        <p:nvSpPr>
+          <p:cNvPr id="23" name="Text 21"/>
+          <p:cNvSpPr/>
+          <p:nvPr/>
+        </p:nvSpPr>
+        <p:spPr>
+          <a:xfrm>
+            <a:off x="6233818" y="1920240"/>
+            <a:ext cx="1409346" cy="219456"/>
           </a:xfrm>
           <a:prstGeom prst="rect">
             <a:avLst/>
@@ -1301,7 +1539,68 @@
           <a:bodyPr wrap="square" rtlCol="0" anchor="t"/>
           <a:lstStyle/>
           <a:p>
-            <a:pPr marL="0" indent="0">
+            <a:pPr indent="0" marL="0">
+              <a:buNone/>
+            </a:pPr>
+            <a:r>
+              <a:rPr lang="en-US" sz="900" dirty="0">
+                <a:solidFill>
+                  <a:srgbClr val="333333"/>
+                </a:solidFill>
+              </a:rPr>
+              <a:t>Search</a:t>
+            </a:r>
+            <a:endParaRPr lang="en-US" sz="900" dirty="0"/>
+          </a:p>
+        </p:txBody>
+      </p:sp>
+      <p:sp>
+        <p:nvSpPr>
+          <p:cNvPr id="24" name="Shape 22"/>
+          <p:cNvSpPr/>
+          <p:nvPr/>
+        </p:nvSpPr>
+        <p:spPr>
+          <a:xfrm>
+            <a:off x="4475378" y="2267712"/>
+            <a:ext cx="1433017" cy="566928"/>
+          </a:xfrm>
+          <a:prstGeom prst="rect">
+            <a:avLst/>
+          </a:prstGeom>
+          <a:solidFill>
+            <a:srgbClr val="FFFFFF"/>
+          </a:solidFill>
+          <a:ln w="12700">
+            <a:solidFill>
+              <a:srgbClr val="888888"/>
+            </a:solidFill>
+            <a:prstDash val="solid"/>
+          </a:ln>
+        </p:spPr>
+      </p:sp>
+      <p:sp>
+        <p:nvSpPr>
+          <p:cNvPr id="25" name="Text 23"/>
+          <p:cNvSpPr/>
+          <p:nvPr/>
+        </p:nvSpPr>
+        <p:spPr>
+          <a:xfrm>
+            <a:off x="4548530" y="2322576"/>
+            <a:ext cx="1286713" cy="457200"/>
+          </a:xfrm>
+          <a:prstGeom prst="rect">
+            <a:avLst/>
+          </a:prstGeom>
+          <a:noFill/>
+          <a:ln/>
+        </p:spPr>
+        <p:txBody>
+          <a:bodyPr wrap="square" rtlCol="0" anchor="t"/>
+          <a:lstStyle/>
+          <a:p>
+            <a:pPr indent="0" marL="0">
               <a:buNone/>
             </a:pPr>
             <a:r>
@@ -1318,13 +1617,13 @@
       </p:sp>
       <p:sp>
         <p:nvSpPr>
-          <p:cNvPr id="22" name="Shape 20"/>
-          <p:cNvSpPr/>
-          <p:nvPr/>
-        </p:nvSpPr>
-        <p:spPr>
-          <a:xfrm>
-            <a:off x="6054700" y="2359152"/>
+          <p:cNvPr id="26" name="Shape 24"/>
+          <p:cNvSpPr/>
+          <p:nvPr/>
+        </p:nvSpPr>
+        <p:spPr>
+          <a:xfrm>
+            <a:off x="6054700" y="2267712"/>
             <a:ext cx="1433017" cy="566928"/>
           </a:xfrm>
           <a:prstGeom prst="rect">
@@ -1340,23 +1639,16 @@
             <a:prstDash val="solid"/>
           </a:ln>
         </p:spPr>
-        <p:txBody>
-          <a:bodyPr/>
-          <a:lstStyle/>
-          <a:p>
-            <a:endParaRPr lang="en-CA"/>
-          </a:p>
-        </p:txBody>
-      </p:sp>
-      <p:sp>
-        <p:nvSpPr>
-          <p:cNvPr id="23" name="Text 21"/>
-          <p:cNvSpPr/>
-          <p:nvPr/>
-        </p:nvSpPr>
-        <p:spPr>
-          <a:xfrm>
-            <a:off x="6127852" y="2414016"/>
+      </p:sp>
+      <p:sp>
+        <p:nvSpPr>
+          <p:cNvPr id="27" name="Text 25"/>
+          <p:cNvSpPr/>
+          <p:nvPr/>
+        </p:nvSpPr>
+        <p:spPr>
+          <a:xfrm>
+            <a:off x="6127852" y="2322576"/>
             <a:ext cx="1286713" cy="457200"/>
           </a:xfrm>
           <a:prstGeom prst="rect">
@@ -1369,7 +1661,7 @@
           <a:bodyPr wrap="square" rtlCol="0" anchor="t"/>
           <a:lstStyle/>
           <a:p>
-            <a:pPr marL="0" indent="0">
+            <a:pPr indent="0" marL="0">
               <a:buNone/>
             </a:pPr>
             <a:r>
@@ -1386,13 +1678,13 @@
       </p:sp>
       <p:sp>
         <p:nvSpPr>
-          <p:cNvPr id="24" name="Shape 22"/>
-          <p:cNvSpPr/>
-          <p:nvPr/>
-        </p:nvSpPr>
-        <p:spPr>
-          <a:xfrm>
-            <a:off x="4475378" y="3035808"/>
+          <p:cNvPr id="28" name="Shape 26"/>
+          <p:cNvSpPr/>
+          <p:nvPr/>
+        </p:nvSpPr>
+        <p:spPr>
+          <a:xfrm>
+            <a:off x="4475378" y="2944368"/>
             <a:ext cx="1433017" cy="566928"/>
           </a:xfrm>
           <a:prstGeom prst="rect">
@@ -1408,23 +1700,16 @@
             <a:prstDash val="solid"/>
           </a:ln>
         </p:spPr>
-        <p:txBody>
-          <a:bodyPr/>
-          <a:lstStyle/>
-          <a:p>
-            <a:endParaRPr lang="en-CA"/>
-          </a:p>
-        </p:txBody>
-      </p:sp>
-      <p:sp>
-        <p:nvSpPr>
-          <p:cNvPr id="25" name="Text 23"/>
-          <p:cNvSpPr/>
-          <p:nvPr/>
-        </p:nvSpPr>
-        <p:spPr>
-          <a:xfrm>
-            <a:off x="4548530" y="3090672"/>
+      </p:sp>
+      <p:sp>
+        <p:nvSpPr>
+          <p:cNvPr id="29" name="Text 27"/>
+          <p:cNvSpPr/>
+          <p:nvPr/>
+        </p:nvSpPr>
+        <p:spPr>
+          <a:xfrm>
+            <a:off x="4548530" y="2999232"/>
             <a:ext cx="1286713" cy="457200"/>
           </a:xfrm>
           <a:prstGeom prst="rect">
@@ -1437,7 +1722,7 @@
           <a:bodyPr wrap="square" rtlCol="0" anchor="t"/>
           <a:lstStyle/>
           <a:p>
-            <a:pPr marL="0" indent="0">
+            <a:pPr indent="0" marL="0">
               <a:buNone/>
             </a:pPr>
             <a:r>
@@ -1454,13 +1739,13 @@
       </p:sp>
       <p:sp>
         <p:nvSpPr>
-          <p:cNvPr id="26" name="Shape 24"/>
-          <p:cNvSpPr/>
-          <p:nvPr/>
-        </p:nvSpPr>
-        <p:spPr>
-          <a:xfrm>
-            <a:off x="6054700" y="3035808"/>
+          <p:cNvPr id="30" name="Shape 28"/>
+          <p:cNvSpPr/>
+          <p:nvPr/>
+        </p:nvSpPr>
+        <p:spPr>
+          <a:xfrm>
+            <a:off x="6054700" y="2944368"/>
             <a:ext cx="1433017" cy="566928"/>
           </a:xfrm>
           <a:prstGeom prst="rect">
@@ -1476,23 +1761,16 @@
             <a:prstDash val="solid"/>
           </a:ln>
         </p:spPr>
-        <p:txBody>
-          <a:bodyPr/>
-          <a:lstStyle/>
-          <a:p>
-            <a:endParaRPr lang="en-CA"/>
-          </a:p>
-        </p:txBody>
-      </p:sp>
-      <p:sp>
-        <p:nvSpPr>
-          <p:cNvPr id="27" name="Text 25"/>
-          <p:cNvSpPr/>
-          <p:nvPr/>
-        </p:nvSpPr>
-        <p:spPr>
-          <a:xfrm>
-            <a:off x="6127852" y="3090672"/>
+      </p:sp>
+      <p:sp>
+        <p:nvSpPr>
+          <p:cNvPr id="31" name="Text 29"/>
+          <p:cNvSpPr/>
+          <p:nvPr/>
+        </p:nvSpPr>
+        <p:spPr>
+          <a:xfrm>
+            <a:off x="6127852" y="2999232"/>
             <a:ext cx="1286713" cy="457200"/>
           </a:xfrm>
           <a:prstGeom prst="rect">
@@ -1505,7 +1783,7 @@
           <a:bodyPr wrap="square" rtlCol="0" anchor="t"/>
           <a:lstStyle/>
           <a:p>
-            <a:pPr marL="0" indent="0">
+            <a:pPr indent="0" marL="0">
               <a:buNone/>
             </a:pPr>
             <a:r>
@@ -1522,13 +1800,13 @@
       </p:sp>
       <p:sp>
         <p:nvSpPr>
-          <p:cNvPr id="28" name="Shape 26"/>
-          <p:cNvSpPr/>
-          <p:nvPr/>
-        </p:nvSpPr>
-        <p:spPr>
-          <a:xfrm>
-            <a:off x="4475378" y="3712464"/>
+          <p:cNvPr id="32" name="Shape 30"/>
+          <p:cNvSpPr/>
+          <p:nvPr/>
+        </p:nvSpPr>
+        <p:spPr>
+          <a:xfrm>
+            <a:off x="4475378" y="3621024"/>
             <a:ext cx="1433017" cy="566928"/>
           </a:xfrm>
           <a:prstGeom prst="rect">
@@ -1544,23 +1822,16 @@
             <a:prstDash val="solid"/>
           </a:ln>
         </p:spPr>
-        <p:txBody>
-          <a:bodyPr/>
-          <a:lstStyle/>
-          <a:p>
-            <a:endParaRPr lang="en-CA"/>
-          </a:p>
-        </p:txBody>
-      </p:sp>
-      <p:sp>
-        <p:nvSpPr>
-          <p:cNvPr id="29" name="Text 27"/>
-          <p:cNvSpPr/>
-          <p:nvPr/>
-        </p:nvSpPr>
-        <p:spPr>
-          <a:xfrm>
-            <a:off x="4548530" y="3767328"/>
+      </p:sp>
+      <p:sp>
+        <p:nvSpPr>
+          <p:cNvPr id="33" name="Text 31"/>
+          <p:cNvSpPr/>
+          <p:nvPr/>
+        </p:nvSpPr>
+        <p:spPr>
+          <a:xfrm>
+            <a:off x="4548530" y="3675888"/>
             <a:ext cx="1286713" cy="457200"/>
           </a:xfrm>
           <a:prstGeom prst="rect">
@@ -1573,7 +1844,7 @@
           <a:bodyPr wrap="square" rtlCol="0" anchor="t"/>
           <a:lstStyle/>
           <a:p>
-            <a:pPr marL="0" indent="0">
+            <a:pPr indent="0" marL="0">
               <a:buNone/>
             </a:pPr>
             <a:r>
@@ -1590,13 +1861,13 @@
       </p:sp>
       <p:sp>
         <p:nvSpPr>
-          <p:cNvPr id="30" name="Shape 28"/>
-          <p:cNvSpPr/>
-          <p:nvPr/>
-        </p:nvSpPr>
-        <p:spPr>
-          <a:xfrm>
-            <a:off x="6054700" y="3712464"/>
+          <p:cNvPr id="34" name="Shape 32"/>
+          <p:cNvSpPr/>
+          <p:nvPr/>
+        </p:nvSpPr>
+        <p:spPr>
+          <a:xfrm>
+            <a:off x="6054700" y="3621024"/>
             <a:ext cx="1433017" cy="566928"/>
           </a:xfrm>
           <a:prstGeom prst="rect">
@@ -1612,23 +1883,16 @@
             <a:prstDash val="solid"/>
           </a:ln>
         </p:spPr>
-        <p:txBody>
-          <a:bodyPr/>
-          <a:lstStyle/>
-          <a:p>
-            <a:endParaRPr lang="en-CA"/>
-          </a:p>
-        </p:txBody>
-      </p:sp>
-      <p:sp>
-        <p:nvSpPr>
-          <p:cNvPr id="31" name="Text 29"/>
-          <p:cNvSpPr/>
-          <p:nvPr/>
-        </p:nvSpPr>
-        <p:spPr>
-          <a:xfrm>
-            <a:off x="6127852" y="3767328"/>
+      </p:sp>
+      <p:sp>
+        <p:nvSpPr>
+          <p:cNvPr id="35" name="Text 33"/>
+          <p:cNvSpPr/>
+          <p:nvPr/>
+        </p:nvSpPr>
+        <p:spPr>
+          <a:xfrm>
+            <a:off x="6127852" y="3675888"/>
             <a:ext cx="1286713" cy="457200"/>
           </a:xfrm>
           <a:prstGeom prst="rect">
@@ -1641,7 +1905,7 @@
           <a:bodyPr wrap="square" rtlCol="0" anchor="t"/>
           <a:lstStyle/>
           <a:p>
-            <a:pPr marL="0" indent="0">
+            <a:pPr indent="0" marL="0">
               <a:buNone/>
             </a:pPr>
             <a:r>
@@ -1658,7 +1922,7 @@
       </p:sp>
       <p:sp>
         <p:nvSpPr>
-          <p:cNvPr id="32" name="Shape 30"/>
+          <p:cNvPr id="36" name="Shape 34"/>
           <p:cNvSpPr/>
           <p:nvPr/>
         </p:nvSpPr>
@@ -1682,17 +1946,10 @@
             <a:prstDash val="solid"/>
           </a:ln>
         </p:spPr>
-        <p:txBody>
-          <a:bodyPr/>
-          <a:lstStyle/>
-          <a:p>
-            <a:endParaRPr lang="en-CA"/>
-          </a:p>
-        </p:txBody>
-      </p:sp>
-      <p:sp>
-        <p:nvSpPr>
-          <p:cNvPr id="33" name="Text 31"/>
+      </p:sp>
+      <p:sp>
+        <p:nvSpPr>
+          <p:cNvPr id="37" name="Text 35"/>
           <p:cNvSpPr/>
           <p:nvPr/>
         </p:nvSpPr>
@@ -1711,7 +1968,7 @@
           <a:bodyPr wrap="square" rtlCol="0" anchor="ctr"/>
           <a:lstStyle/>
           <a:p>
-            <a:pPr marL="0" indent="0">
+            <a:pPr indent="0" marL="0">
               <a:buNone/>
             </a:pPr>
             <a:r>
@@ -1720,7 +1977,7 @@
                   <a:srgbClr val="111111"/>
                 </a:solidFill>
               </a:rPr>
-              <a:t>3. Log workout (form)</a:t>
+              <a:t>3. Add Workout</a:t>
             </a:r>
             <a:endParaRPr lang="en-US" sz="1400" dirty="0"/>
           </a:p>
@@ -1728,20 +1985,20 @@
       </p:sp>
       <p:sp>
         <p:nvSpPr>
-          <p:cNvPr id="34" name="Shape 32"/>
+          <p:cNvPr id="38" name="Shape 36"/>
           <p:cNvSpPr/>
           <p:nvPr/>
         </p:nvSpPr>
         <p:spPr>
           <a:xfrm>
             <a:off x="8402117" y="1463040"/>
-            <a:ext cx="3240938" cy="384048"/>
-          </a:xfrm>
-          <a:prstGeom prst="rect">
-            <a:avLst/>
-          </a:prstGeom>
-          <a:solidFill>
-            <a:srgbClr val="ECECEC"/>
+            <a:ext cx="3240938" cy="347472"/>
+          </a:xfrm>
+          <a:prstGeom prst="rect">
+            <a:avLst/>
+          </a:prstGeom>
+          <a:solidFill>
+            <a:srgbClr val="C8E6C9"/>
           </a:solidFill>
           <a:ln w="12700">
             <a:solidFill>
@@ -1750,24 +2007,17 @@
             <a:prstDash val="solid"/>
           </a:ln>
         </p:spPr>
-        <p:txBody>
-          <a:bodyPr/>
-          <a:lstStyle/>
-          <a:p>
-            <a:endParaRPr lang="en-CA"/>
-          </a:p>
-        </p:txBody>
-      </p:sp>
-      <p:sp>
-        <p:nvSpPr>
-          <p:cNvPr id="35" name="Text 33"/>
+      </p:sp>
+      <p:sp>
+        <p:nvSpPr>
+          <p:cNvPr id="39" name="Text 37"/>
           <p:cNvSpPr/>
           <p:nvPr/>
         </p:nvSpPr>
         <p:spPr>
           <a:xfrm>
             <a:off x="8475269" y="1517904"/>
-            <a:ext cx="3094634" cy="274320"/>
+            <a:ext cx="3094634" cy="237744"/>
           </a:xfrm>
           <a:prstGeom prst="rect">
             <a:avLst/>
@@ -1779,7 +2029,7 @@
           <a:bodyPr wrap="square" rtlCol="0" anchor="t"/>
           <a:lstStyle/>
           <a:p>
-            <a:pPr marL="0" indent="0">
+            <a:pPr indent="0" marL="0">
               <a:buNone/>
             </a:pPr>
             <a:r>
@@ -1788,7 +2038,7 @@
                   <a:srgbClr val="333333"/>
                 </a:solidFill>
               </a:rPr>
-              <a:t>Same header + nav</a:t>
+              <a:t>Header (matches Workouts)</a:t>
             </a:r>
             <a:endParaRPr lang="en-US" sz="900" dirty="0"/>
           </a:p>
@@ -1796,14 +2046,14 @@
       </p:sp>
       <p:sp>
         <p:nvSpPr>
-          <p:cNvPr id="36" name="Shape 34"/>
-          <p:cNvSpPr/>
-          <p:nvPr/>
-        </p:nvSpPr>
-        <p:spPr>
-          <a:xfrm>
-            <a:off x="8402117" y="1938528"/>
-            <a:ext cx="3240938" cy="438912"/>
+          <p:cNvPr id="40" name="Shape 38"/>
+          <p:cNvSpPr/>
+          <p:nvPr/>
+        </p:nvSpPr>
+        <p:spPr>
+          <a:xfrm>
+            <a:off x="8402117" y="1883664"/>
+            <a:ext cx="3240938" cy="365760"/>
           </a:xfrm>
           <a:prstGeom prst="rect">
             <a:avLst/>
@@ -1818,24 +2068,17 @@
             <a:prstDash val="solid"/>
           </a:ln>
         </p:spPr>
-        <p:txBody>
-          <a:bodyPr/>
-          <a:lstStyle/>
-          <a:p>
-            <a:endParaRPr lang="en-CA"/>
-          </a:p>
-        </p:txBody>
-      </p:sp>
-      <p:sp>
-        <p:nvSpPr>
-          <p:cNvPr id="37" name="Text 35"/>
-          <p:cNvSpPr/>
-          <p:nvPr/>
-        </p:nvSpPr>
-        <p:spPr>
-          <a:xfrm>
-            <a:off x="8475269" y="1993392"/>
-            <a:ext cx="3094634" cy="329184"/>
+      </p:sp>
+      <p:sp>
+        <p:nvSpPr>
+          <p:cNvPr id="41" name="Text 39"/>
+          <p:cNvSpPr/>
+          <p:nvPr/>
+        </p:nvSpPr>
+        <p:spPr>
+          <a:xfrm>
+            <a:off x="8475269" y="1938528"/>
+            <a:ext cx="3094634" cy="256032"/>
           </a:xfrm>
           <a:prstGeom prst="rect">
             <a:avLst/>
@@ -1847,7 +2090,7 @@
           <a:bodyPr wrap="square" rtlCol="0" anchor="t"/>
           <a:lstStyle/>
           <a:p>
-            <a:pPr marL="0" indent="0">
+            <a:pPr indent="0" marL="0">
               <a:buNone/>
             </a:pPr>
             <a:r>
@@ -1856,7 +2099,7 @@
                   <a:srgbClr val="333333"/>
                 </a:solidFill>
               </a:rPr>
-              <a:t>Activity / type</a:t>
+              <a:t>Workout Name</a:t>
             </a:r>
             <a:endParaRPr lang="en-US" sz="1000" dirty="0"/>
           </a:p>
@@ -1864,14 +2107,14 @@
       </p:sp>
       <p:sp>
         <p:nvSpPr>
-          <p:cNvPr id="38" name="Shape 36"/>
-          <p:cNvSpPr/>
-          <p:nvPr/>
-        </p:nvSpPr>
-        <p:spPr>
-          <a:xfrm>
-            <a:off x="8402117" y="2505456"/>
-            <a:ext cx="3240938" cy="438912"/>
+          <p:cNvPr id="42" name="Shape 40"/>
+          <p:cNvSpPr/>
+          <p:nvPr/>
+        </p:nvSpPr>
+        <p:spPr>
+          <a:xfrm>
+            <a:off x="8402117" y="2340864"/>
+            <a:ext cx="3240938" cy="365760"/>
           </a:xfrm>
           <a:prstGeom prst="rect">
             <a:avLst/>
@@ -1886,24 +2129,17 @@
             <a:prstDash val="solid"/>
           </a:ln>
         </p:spPr>
-        <p:txBody>
-          <a:bodyPr/>
-          <a:lstStyle/>
-          <a:p>
-            <a:endParaRPr lang="en-CA"/>
-          </a:p>
-        </p:txBody>
-      </p:sp>
-      <p:sp>
-        <p:nvSpPr>
-          <p:cNvPr id="39" name="Text 37"/>
-          <p:cNvSpPr/>
-          <p:nvPr/>
-        </p:nvSpPr>
-        <p:spPr>
-          <a:xfrm>
-            <a:off x="8475269" y="2560320"/>
-            <a:ext cx="3094634" cy="329184"/>
+      </p:sp>
+      <p:sp>
+        <p:nvSpPr>
+          <p:cNvPr id="43" name="Text 41"/>
+          <p:cNvSpPr/>
+          <p:nvPr/>
+        </p:nvSpPr>
+        <p:spPr>
+          <a:xfrm>
+            <a:off x="8475269" y="2395728"/>
+            <a:ext cx="3094634" cy="256032"/>
           </a:xfrm>
           <a:prstGeom prst="rect">
             <a:avLst/>
@@ -1915,7 +2151,7 @@
           <a:bodyPr wrap="square" rtlCol="0" anchor="t"/>
           <a:lstStyle/>
           <a:p>
-            <a:pPr marL="0" indent="0">
+            <a:pPr indent="0" marL="0">
               <a:buNone/>
             </a:pPr>
             <a:r>
@@ -1924,7 +2160,7 @@
                   <a:srgbClr val="333333"/>
                 </a:solidFill>
               </a:rPr>
-              <a:t>Duration (minutes)</a:t>
+              <a:t>Category (dropdown)</a:t>
             </a:r>
             <a:endParaRPr lang="en-US" sz="1000" dirty="0"/>
           </a:p>
@@ -1932,14 +2168,14 @@
       </p:sp>
       <p:sp>
         <p:nvSpPr>
-          <p:cNvPr id="40" name="Shape 38"/>
-          <p:cNvSpPr/>
-          <p:nvPr/>
-        </p:nvSpPr>
-        <p:spPr>
-          <a:xfrm>
-            <a:off x="8402117" y="3072384"/>
-            <a:ext cx="3240938" cy="438912"/>
+          <p:cNvPr id="44" name="Shape 42"/>
+          <p:cNvSpPr/>
+          <p:nvPr/>
+        </p:nvSpPr>
+        <p:spPr>
+          <a:xfrm>
+            <a:off x="8402117" y="2798064"/>
+            <a:ext cx="3240938" cy="365760"/>
           </a:xfrm>
           <a:prstGeom prst="rect">
             <a:avLst/>
@@ -1954,24 +2190,17 @@
             <a:prstDash val="solid"/>
           </a:ln>
         </p:spPr>
-        <p:txBody>
-          <a:bodyPr/>
-          <a:lstStyle/>
-          <a:p>
-            <a:endParaRPr lang="en-CA"/>
-          </a:p>
-        </p:txBody>
-      </p:sp>
-      <p:sp>
-        <p:nvSpPr>
-          <p:cNvPr id="41" name="Text 39"/>
-          <p:cNvSpPr/>
-          <p:nvPr/>
-        </p:nvSpPr>
-        <p:spPr>
-          <a:xfrm>
-            <a:off x="8475269" y="3127248"/>
-            <a:ext cx="3094634" cy="329184"/>
+      </p:sp>
+      <p:sp>
+        <p:nvSpPr>
+          <p:cNvPr id="45" name="Text 43"/>
+          <p:cNvSpPr/>
+          <p:nvPr/>
+        </p:nvSpPr>
+        <p:spPr>
+          <a:xfrm>
+            <a:off x="8475269" y="2852928"/>
+            <a:ext cx="3094634" cy="256032"/>
           </a:xfrm>
           <a:prstGeom prst="rect">
             <a:avLst/>
@@ -1983,7 +2212,7 @@
           <a:bodyPr wrap="square" rtlCol="0" anchor="t"/>
           <a:lstStyle/>
           <a:p>
-            <a:pPr marL="0" indent="0">
+            <a:pPr indent="0" marL="0">
               <a:buNone/>
             </a:pPr>
             <a:r>
@@ -1992,7 +2221,7 @@
                   <a:srgbClr val="333333"/>
                 </a:solidFill>
               </a:rPr>
-              <a:t>Date</a:t>
+              <a:t>Duration (mins)</a:t>
             </a:r>
             <a:endParaRPr lang="en-US" sz="1000" dirty="0"/>
           </a:p>
@@ -2000,14 +2229,14 @@
       </p:sp>
       <p:sp>
         <p:nvSpPr>
-          <p:cNvPr id="42" name="Shape 40"/>
-          <p:cNvSpPr/>
-          <p:nvPr/>
-        </p:nvSpPr>
-        <p:spPr>
-          <a:xfrm>
-            <a:off x="8402117" y="3639312"/>
-            <a:ext cx="3240938" cy="438912"/>
+          <p:cNvPr id="46" name="Shape 44"/>
+          <p:cNvSpPr/>
+          <p:nvPr/>
+        </p:nvSpPr>
+        <p:spPr>
+          <a:xfrm>
+            <a:off x="8402117" y="3255264"/>
+            <a:ext cx="3240938" cy="365760"/>
           </a:xfrm>
           <a:prstGeom prst="rect">
             <a:avLst/>
@@ -2022,24 +2251,17 @@
             <a:prstDash val="solid"/>
           </a:ln>
         </p:spPr>
-        <p:txBody>
-          <a:bodyPr/>
-          <a:lstStyle/>
-          <a:p>
-            <a:endParaRPr lang="en-CA"/>
-          </a:p>
-        </p:txBody>
-      </p:sp>
-      <p:sp>
-        <p:nvSpPr>
-          <p:cNvPr id="43" name="Text 41"/>
-          <p:cNvSpPr/>
-          <p:nvPr/>
-        </p:nvSpPr>
-        <p:spPr>
-          <a:xfrm>
-            <a:off x="8475269" y="3694176"/>
-            <a:ext cx="3094634" cy="329184"/>
+      </p:sp>
+      <p:sp>
+        <p:nvSpPr>
+          <p:cNvPr id="47" name="Text 45"/>
+          <p:cNvSpPr/>
+          <p:nvPr/>
+        </p:nvSpPr>
+        <p:spPr>
+          <a:xfrm>
+            <a:off x="8475269" y="3310128"/>
+            <a:ext cx="3094634" cy="256032"/>
           </a:xfrm>
           <a:prstGeom prst="rect">
             <a:avLst/>
@@ -2051,7 +2273,7 @@
           <a:bodyPr wrap="square" rtlCol="0" anchor="t"/>
           <a:lstStyle/>
           <a:p>
-            <a:pPr marL="0" indent="0">
+            <a:pPr indent="0" marL="0">
               <a:buNone/>
             </a:pPr>
             <a:r>
@@ -2060,7 +2282,7 @@
                   <a:srgbClr val="333333"/>
                 </a:solidFill>
               </a:rPr>
-              <a:t>Notes (optional)</a:t>
+              <a:t>Calories Burned</a:t>
             </a:r>
             <a:endParaRPr lang="en-US" sz="1000" dirty="0"/>
           </a:p>
@@ -2068,14 +2290,14 @@
       </p:sp>
       <p:sp>
         <p:nvSpPr>
-          <p:cNvPr id="44" name="Shape 42"/>
-          <p:cNvSpPr/>
-          <p:nvPr/>
-        </p:nvSpPr>
-        <p:spPr>
-          <a:xfrm>
-            <a:off x="8402117" y="4206240"/>
-            <a:ext cx="1458422" cy="384048"/>
+          <p:cNvPr id="48" name="Shape 46"/>
+          <p:cNvSpPr/>
+          <p:nvPr/>
+        </p:nvSpPr>
+        <p:spPr>
+          <a:xfrm>
+            <a:off x="8402117" y="3712464"/>
+            <a:ext cx="1782516" cy="347472"/>
           </a:xfrm>
           <a:prstGeom prst="rect">
             <a:avLst/>
@@ -2090,24 +2312,17 @@
             <a:prstDash val="solid"/>
           </a:ln>
         </p:spPr>
-        <p:txBody>
-          <a:bodyPr/>
-          <a:lstStyle/>
-          <a:p>
-            <a:endParaRPr lang="en-CA"/>
-          </a:p>
-        </p:txBody>
-      </p:sp>
-      <p:sp>
-        <p:nvSpPr>
-          <p:cNvPr id="45" name="Text 43"/>
-          <p:cNvSpPr/>
-          <p:nvPr/>
-        </p:nvSpPr>
-        <p:spPr>
-          <a:xfrm>
-            <a:off x="8475269" y="4261104"/>
-            <a:ext cx="1312118" cy="274320"/>
+      </p:sp>
+      <p:sp>
+        <p:nvSpPr>
+          <p:cNvPr id="49" name="Text 47"/>
+          <p:cNvSpPr/>
+          <p:nvPr/>
+        </p:nvSpPr>
+        <p:spPr>
+          <a:xfrm>
+            <a:off x="8475269" y="3767328"/>
+            <a:ext cx="1636212" cy="237744"/>
           </a:xfrm>
           <a:prstGeom prst="rect">
             <a:avLst/>
@@ -2119,37 +2334,37 @@
           <a:bodyPr wrap="square" rtlCol="0" anchor="t"/>
           <a:lstStyle/>
           <a:p>
-            <a:pPr marL="0" indent="0">
+            <a:pPr indent="0" marL="0">
               <a:buNone/>
             </a:pPr>
             <a:r>
-              <a:rPr lang="en-US" sz="1100" dirty="0">
+              <a:rPr lang="en-US" sz="900" dirty="0">
                 <a:solidFill>
                   <a:srgbClr val="333333"/>
                 </a:solidFill>
               </a:rPr>
-              <a:t>Submit</a:t>
-            </a:r>
-            <a:endParaRPr lang="en-US" sz="1100" dirty="0"/>
-          </a:p>
-        </p:txBody>
-      </p:sp>
-      <p:sp>
-        <p:nvSpPr>
-          <p:cNvPr id="46" name="Shape 44"/>
-          <p:cNvSpPr/>
-          <p:nvPr/>
-        </p:nvSpPr>
-        <p:spPr>
-          <a:xfrm>
-            <a:off x="10184633" y="4206240"/>
-            <a:ext cx="1458422" cy="384048"/>
-          </a:xfrm>
-          <a:prstGeom prst="rect">
-            <a:avLst/>
-          </a:prstGeom>
-          <a:solidFill>
-            <a:srgbClr val="FFF8E1"/>
+              <a:t>Muscle + Get Exercises</a:t>
+            </a:r>
+            <a:endParaRPr lang="en-US" sz="900" dirty="0"/>
+          </a:p>
+        </p:txBody>
+      </p:sp>
+      <p:sp>
+        <p:nvSpPr>
+          <p:cNvPr id="50" name="Shape 48"/>
+          <p:cNvSpPr/>
+          <p:nvPr/>
+        </p:nvSpPr>
+        <p:spPr>
+          <a:xfrm>
+            <a:off x="10281861" y="3712464"/>
+            <a:ext cx="1361194" cy="347472"/>
+          </a:xfrm>
+          <a:prstGeom prst="rect">
+            <a:avLst/>
+          </a:prstGeom>
+          <a:solidFill>
+            <a:srgbClr val="FFFFFF"/>
           </a:solidFill>
           <a:ln w="12700">
             <a:solidFill>
@@ -2158,24 +2373,17 @@
             <a:prstDash val="solid"/>
           </a:ln>
         </p:spPr>
-        <p:txBody>
-          <a:bodyPr/>
-          <a:lstStyle/>
-          <a:p>
-            <a:endParaRPr lang="en-CA"/>
-          </a:p>
-        </p:txBody>
-      </p:sp>
-      <p:sp>
-        <p:nvSpPr>
-          <p:cNvPr id="47" name="Text 45"/>
-          <p:cNvSpPr/>
-          <p:nvPr/>
-        </p:nvSpPr>
-        <p:spPr>
-          <a:xfrm>
-            <a:off x="10257785" y="4261104"/>
-            <a:ext cx="1312118" cy="274320"/>
+      </p:sp>
+      <p:sp>
+        <p:nvSpPr>
+          <p:cNvPr id="51" name="Text 49"/>
+          <p:cNvSpPr/>
+          <p:nvPr/>
+        </p:nvSpPr>
+        <p:spPr>
+          <a:xfrm>
+            <a:off x="10355013" y="3767328"/>
+            <a:ext cx="1214890" cy="237744"/>
           </a:xfrm>
           <a:prstGeom prst="rect">
             <a:avLst/>
@@ -2187,7 +2395,7 @@
           <a:bodyPr wrap="square" rtlCol="0" anchor="t"/>
           <a:lstStyle/>
           <a:p>
-            <a:pPr marL="0" indent="0">
+            <a:pPr indent="0" marL="0">
               <a:buNone/>
             </a:pPr>
             <a:r>
@@ -2196,23 +2404,70 @@
                   <a:srgbClr val="333333"/>
                 </a:solidFill>
               </a:rPr>
-              <a:t>Custom error messages</a:t>
+              <a:t>Suggested list</a:t>
             </a:r>
             <a:endParaRPr lang="en-US" sz="900" dirty="0"/>
           </a:p>
-          <a:p>
-            <a:pPr marL="0" indent="0">
+        </p:txBody>
+      </p:sp>
+      <p:sp>
+        <p:nvSpPr>
+          <p:cNvPr id="52" name="Shape 50"/>
+          <p:cNvSpPr/>
+          <p:nvPr/>
+        </p:nvSpPr>
+        <p:spPr>
+          <a:xfrm>
+            <a:off x="8402117" y="4151376"/>
+            <a:ext cx="3240938" cy="365760"/>
+          </a:xfrm>
+          <a:prstGeom prst="rect">
+            <a:avLst/>
+          </a:prstGeom>
+          <a:solidFill>
+            <a:srgbClr val="C8E6C9"/>
+          </a:solidFill>
+          <a:ln w="12700">
+            <a:solidFill>
+              <a:srgbClr val="888888"/>
+            </a:solidFill>
+            <a:prstDash val="solid"/>
+          </a:ln>
+        </p:spPr>
+      </p:sp>
+      <p:sp>
+        <p:nvSpPr>
+          <p:cNvPr id="53" name="Text 51"/>
+          <p:cNvSpPr/>
+          <p:nvPr/>
+        </p:nvSpPr>
+        <p:spPr>
+          <a:xfrm>
+            <a:off x="8475269" y="4206240"/>
+            <a:ext cx="3094634" cy="256032"/>
+          </a:xfrm>
+          <a:prstGeom prst="rect">
+            <a:avLst/>
+          </a:prstGeom>
+          <a:noFill/>
+          <a:ln/>
+        </p:spPr>
+        <p:txBody>
+          <a:bodyPr wrap="square" rtlCol="0" anchor="t"/>
+          <a:lstStyle/>
+          <a:p>
+            <a:pPr indent="0" marL="0">
               <a:buNone/>
             </a:pPr>
             <a:r>
-              <a:rPr lang="en-US" sz="900" dirty="0">
+              <a:rPr lang="en-US" sz="1000" dirty="0">
                 <a:solidFill>
                   <a:srgbClr val="333333"/>
                 </a:solidFill>
               </a:rPr>
-              <a:t>(near fields)</a:t>
-            </a:r>
-            <a:endParaRPr lang="en-US" sz="900" dirty="0"/>
+              <a:t>+ Add Workout (submit) + JS validation / errors</a:t>
+            </a:r>
+            <a:endParaRPr lang="en-US" sz="1000" dirty="0"/>
           </a:p>
         </p:txBody>
       </p:sp>
@@ -2517,319 +2772,4 @@
     </a:ext>
   </a:extLst>
 </a:theme>
-</file>
-
-<file path=ppt/theme/theme2.xml><?xml version="1.0" encoding="utf-8"?>
-<a:theme xmlns:a="http://schemas.openxmlformats.org/drawingml/2006/main" name="Office Theme">
-  <a:themeElements>
-    <a:clrScheme name="Office">
-      <a:dk1>
-        <a:sysClr val="windowText" lastClr="000000"/>
-      </a:dk1>
-      <a:lt1>
-        <a:sysClr val="window" lastClr="FFFFFF"/>
-      </a:lt1>
-      <a:dk2>
-        <a:srgbClr val="0E2841"/>
-      </a:dk2>
-      <a:lt2>
-        <a:srgbClr val="E8E8E8"/>
-      </a:lt2>
-      <a:accent1>
-        <a:srgbClr val="156082"/>
-      </a:accent1>
-      <a:accent2>
-        <a:srgbClr val="E97132"/>
-      </a:accent2>
-      <a:accent3>
-        <a:srgbClr val="196B24"/>
-      </a:accent3>
-      <a:accent4>
-        <a:srgbClr val="0F9ED5"/>
-      </a:accent4>
-      <a:accent5>
-        <a:srgbClr val="A02B93"/>
-      </a:accent5>
-      <a:accent6>
-        <a:srgbClr val="4EA72E"/>
-      </a:accent6>
-      <a:hlink>
-        <a:srgbClr val="467886"/>
-      </a:hlink>
-      <a:folHlink>
-        <a:srgbClr val="96607D"/>
-      </a:folHlink>
-    </a:clrScheme>
-    <a:fontScheme name="Office">
-      <a:majorFont>
-        <a:latin typeface="Aptos Display" panose="02110004020202020204"/>
-        <a:ea typeface=""/>
-        <a:cs typeface=""/>
-        <a:font script="Jpan" typeface="游ゴシック Light"/>
-        <a:font script="Hang" typeface="맑은 고딕"/>
-        <a:font script="Hans" typeface="等线 Light"/>
-        <a:font script="Hant" typeface="新細明體"/>
-        <a:font script="Arab" typeface="Times New Roman"/>
-        <a:font script="Hebr" typeface="Times New Roman"/>
-        <a:font script="Thai" typeface="Angsana New"/>
-        <a:font script="Ethi" typeface="Nyala"/>
-        <a:font script="Beng" typeface="Vrinda"/>
-        <a:font script="Gujr" typeface="Shruti"/>
-        <a:font script="Khmr" typeface="MoolBoran"/>
-        <a:font script="Knda" typeface="Tunga"/>
-        <a:font script="Guru" typeface="Raavi"/>
-        <a:font script="Cans" typeface="Euphemia"/>
-        <a:font script="Cher" typeface="Plantagenet Cherokee"/>
-        <a:font script="Yiii" typeface="Microsoft Yi Baiti"/>
-        <a:font script="Tibt" typeface="Microsoft Himalaya"/>
-        <a:font script="Thaa" typeface="MV Boli"/>
-        <a:font script="Deva" typeface="Mangal"/>
-        <a:font script="Telu" typeface="Gautami"/>
-        <a:font script="Taml" typeface="Latha"/>
-        <a:font script="Syrc" typeface="Estrangelo Edessa"/>
-        <a:font script="Orya" typeface="Kalinga"/>
-        <a:font script="Mlym" typeface="Kartika"/>
-        <a:font script="Laoo" typeface="DokChampa"/>
-        <a:font script="Sinh" typeface="Iskoola Pota"/>
-        <a:font script="Mong" typeface="Mongolian Baiti"/>
-        <a:font script="Viet" typeface="Times New Roman"/>
-        <a:font script="Uigh" typeface="Microsoft Uighur"/>
-        <a:font script="Geor" typeface="Sylfaen"/>
-        <a:font script="Armn" typeface="Arial"/>
-        <a:font script="Bugi" typeface="Leelawadee UI"/>
-        <a:font script="Bopo" typeface="Microsoft JhengHei"/>
-        <a:font script="Java" typeface="Javanese Text"/>
-        <a:font script="Lisu" typeface="Segoe UI"/>
-        <a:font script="Mymr" typeface="Myanmar Text"/>
-        <a:font script="Nkoo" typeface="Ebrima"/>
-        <a:font script="Olck" typeface="Nirmala UI"/>
-        <a:font script="Osma" typeface="Ebrima"/>
-        <a:font script="Phag" typeface="Phagspa"/>
-        <a:font script="Syrn" typeface="Estrangelo Edessa"/>
-        <a:font script="Syrj" typeface="Estrangelo Edessa"/>
-        <a:font script="Syre" typeface="Estrangelo Edessa"/>
-        <a:font script="Sora" typeface="Nirmala UI"/>
-        <a:font script="Tale" typeface="Microsoft Tai Le"/>
-        <a:font script="Talu" typeface="Microsoft New Tai Lue"/>
-        <a:font script="Tfng" typeface="Ebrima"/>
-      </a:majorFont>
-      <a:minorFont>
-        <a:latin typeface="Aptos" panose="02110004020202020204"/>
-        <a:ea typeface=""/>
-        <a:cs typeface=""/>
-        <a:font script="Jpan" typeface="游ゴシック"/>
-        <a:font script="Hang" typeface="맑은 고딕"/>
-        <a:font script="Hans" typeface="等线"/>
-        <a:font script="Hant" typeface="新細明體"/>
-        <a:font script="Arab" typeface="Arial"/>
-        <a:font script="Hebr" typeface="Arial"/>
-        <a:font script="Thai" typeface="Cordia New"/>
-        <a:font script="Ethi" typeface="Nyala"/>
-        <a:font script="Beng" typeface="Vrinda"/>
-        <a:font script="Gujr" typeface="Shruti"/>
-        <a:font script="Khmr" typeface="DaunPenh"/>
-        <a:font script="Knda" typeface="Tunga"/>
-        <a:font script="Guru" typeface="Raavi"/>
-        <a:font script="Cans" typeface="Euphemia"/>
-        <a:font script="Cher" typeface="Plantagenet Cherokee"/>
-        <a:font script="Yiii" typeface="Microsoft Yi Baiti"/>
-        <a:font script="Tibt" typeface="Microsoft Himalaya"/>
-        <a:font script="Thaa" typeface="MV Boli"/>
-        <a:font script="Deva" typeface="Mangal"/>
-        <a:font script="Telu" typeface="Gautami"/>
-        <a:font script="Taml" typeface="Latha"/>
-        <a:font script="Syrc" typeface="Estrangelo Edessa"/>
-        <a:font script="Orya" typeface="Kalinga"/>
-        <a:font script="Mlym" typeface="Kartika"/>
-        <a:font script="Laoo" typeface="DokChampa"/>
-        <a:font script="Sinh" typeface="Iskoola Pota"/>
-        <a:font script="Mong" typeface="Mongolian Baiti"/>
-        <a:font script="Viet" typeface="Arial"/>
-        <a:font script="Uigh" typeface="Microsoft Uighur"/>
-        <a:font script="Geor" typeface="Sylfaen"/>
-        <a:font script="Armn" typeface="Arial"/>
-        <a:font script="Bugi" typeface="Leelawadee UI"/>
-        <a:font script="Bopo" typeface="Microsoft JhengHei"/>
-        <a:font script="Java" typeface="Javanese Text"/>
-        <a:font script="Lisu" typeface="Segoe UI"/>
-        <a:font script="Mymr" typeface="Myanmar Text"/>
-        <a:font script="Nkoo" typeface="Ebrima"/>
-        <a:font script="Olck" typeface="Nirmala UI"/>
-        <a:font script="Osma" typeface="Ebrima"/>
-        <a:font script="Phag" typeface="Phagspa"/>
-        <a:font script="Syrn" typeface="Estrangelo Edessa"/>
-        <a:font script="Syrj" typeface="Estrangelo Edessa"/>
-        <a:font script="Syre" typeface="Estrangelo Edessa"/>
-        <a:font script="Sora" typeface="Nirmala UI"/>
-        <a:font script="Tale" typeface="Microsoft Tai Le"/>
-        <a:font script="Talu" typeface="Microsoft New Tai Lue"/>
-        <a:font script="Tfng" typeface="Ebrima"/>
-      </a:minorFont>
-    </a:fontScheme>
-    <a:fmtScheme name="Office">
-      <a:fillStyleLst>
-        <a:solidFill>
-          <a:schemeClr val="phClr"/>
-        </a:solidFill>
-        <a:gradFill rotWithShape="1">
-          <a:gsLst>
-            <a:gs pos="0">
-              <a:schemeClr val="phClr">
-                <a:lumMod val="110000"/>
-                <a:satMod val="105000"/>
-                <a:tint val="67000"/>
-              </a:schemeClr>
-            </a:gs>
-            <a:gs pos="50000">
-              <a:schemeClr val="phClr">
-                <a:lumMod val="105000"/>
-                <a:satMod val="103000"/>
-                <a:tint val="73000"/>
-              </a:schemeClr>
-            </a:gs>
-            <a:gs pos="100000">
-              <a:schemeClr val="phClr">
-                <a:lumMod val="105000"/>
-                <a:satMod val="109000"/>
-                <a:tint val="81000"/>
-              </a:schemeClr>
-            </a:gs>
-          </a:gsLst>
-          <a:lin ang="5400000" scaled="0"/>
-        </a:gradFill>
-        <a:gradFill rotWithShape="1">
-          <a:gsLst>
-            <a:gs pos="0">
-              <a:schemeClr val="phClr">
-                <a:satMod val="103000"/>
-                <a:lumMod val="102000"/>
-                <a:tint val="94000"/>
-              </a:schemeClr>
-            </a:gs>
-            <a:gs pos="50000">
-              <a:schemeClr val="phClr">
-                <a:satMod val="110000"/>
-                <a:lumMod val="100000"/>
-                <a:shade val="100000"/>
-              </a:schemeClr>
-            </a:gs>
-            <a:gs pos="100000">
-              <a:schemeClr val="phClr">
-                <a:lumMod val="99000"/>
-                <a:satMod val="120000"/>
-                <a:shade val="78000"/>
-              </a:schemeClr>
-            </a:gs>
-          </a:gsLst>
-          <a:lin ang="5400000" scaled="0"/>
-        </a:gradFill>
-      </a:fillStyleLst>
-      <a:lnStyleLst>
-        <a:ln w="12700" cap="flat" cmpd="sng" algn="ctr">
-          <a:solidFill>
-            <a:schemeClr val="phClr"/>
-          </a:solidFill>
-          <a:prstDash val="solid"/>
-          <a:miter lim="800000"/>
-        </a:ln>
-        <a:ln w="19050" cap="flat" cmpd="sng" algn="ctr">
-          <a:solidFill>
-            <a:schemeClr val="phClr"/>
-          </a:solidFill>
-          <a:prstDash val="solid"/>
-          <a:miter lim="800000"/>
-        </a:ln>
-        <a:ln w="25400" cap="flat" cmpd="sng" algn="ctr">
-          <a:solidFill>
-            <a:schemeClr val="phClr"/>
-          </a:solidFill>
-          <a:prstDash val="solid"/>
-          <a:miter lim="800000"/>
-        </a:ln>
-      </a:lnStyleLst>
-      <a:effectStyleLst>
-        <a:effectStyle>
-          <a:effectLst/>
-        </a:effectStyle>
-        <a:effectStyle>
-          <a:effectLst/>
-        </a:effectStyle>
-        <a:effectStyle>
-          <a:effectLst>
-            <a:outerShdw blurRad="57150" dist="19050" dir="5400000" algn="ctr" rotWithShape="0">
-              <a:srgbClr val="000000">
-                <a:alpha val="63000"/>
-              </a:srgbClr>
-            </a:outerShdw>
-          </a:effectLst>
-        </a:effectStyle>
-      </a:effectStyleLst>
-      <a:bgFillStyleLst>
-        <a:solidFill>
-          <a:schemeClr val="phClr"/>
-        </a:solidFill>
-        <a:solidFill>
-          <a:schemeClr val="phClr">
-            <a:tint val="95000"/>
-            <a:satMod val="170000"/>
-          </a:schemeClr>
-        </a:solidFill>
-        <a:gradFill rotWithShape="1">
-          <a:gsLst>
-            <a:gs pos="0">
-              <a:schemeClr val="phClr">
-                <a:tint val="93000"/>
-                <a:satMod val="150000"/>
-                <a:shade val="98000"/>
-                <a:lumMod val="102000"/>
-              </a:schemeClr>
-            </a:gs>
-            <a:gs pos="50000">
-              <a:schemeClr val="phClr">
-                <a:tint val="98000"/>
-                <a:satMod val="130000"/>
-                <a:shade val="90000"/>
-                <a:lumMod val="103000"/>
-              </a:schemeClr>
-            </a:gs>
-            <a:gs pos="100000">
-              <a:schemeClr val="phClr">
-                <a:shade val="63000"/>
-                <a:satMod val="120000"/>
-              </a:schemeClr>
-            </a:gs>
-          </a:gsLst>
-          <a:lin ang="5400000" scaled="0"/>
-        </a:gradFill>
-      </a:bgFillStyleLst>
-    </a:fmtScheme>
-  </a:themeElements>
-  <a:objectDefaults>
-    <a:lnDef>
-      <a:spPr/>
-      <a:bodyPr/>
-      <a:lstStyle/>
-      <a:style>
-        <a:lnRef idx="2">
-          <a:schemeClr val="accent1"/>
-        </a:lnRef>
-        <a:fillRef idx="0">
-          <a:schemeClr val="accent1"/>
-        </a:fillRef>
-        <a:effectRef idx="1">
-          <a:schemeClr val="accent1"/>
-        </a:effectRef>
-        <a:fontRef idx="minor">
-          <a:schemeClr val="tx1"/>
-        </a:fontRef>
-      </a:style>
-    </a:lnDef>
-  </a:objectDefaults>
-  <a:extraClrSchemeLst/>
-  <a:extLst>
-    <a:ext uri="{05A4C25C-085E-4340-85A3-A5531E510DB2}">
-      <thm15:themeFamily xmlns:thm15="http://schemas.microsoft.com/office/thememl/2012/main" name="Office Theme" id="{2E142A2C-CD16-42D6-873A-C26D2A0506FA}" vid="{1BDDFF52-6CD6-40A5-AB3C-68EB2F1E4D0A}"/>
-    </a:ext>
-  </a:extLst>
-</a:theme>
 </file>
</xml_diff>